<commit_message>
feat: added the demo video
</commit_message>
<xml_diff>
--- a/StockSense-Final-Presentation.pptx
+++ b/StockSense-Final-Presentation.pptx
@@ -2336,7 +2336,7 @@
           <a:p>
             <a:pPr/>
             <a:r>
-              <a:t>To be transparent about status: init, fmt and validate all pass. Plan, apply and destroy need an AWS account with credentials, which my development machine didn't have - the plan stops exactly at the credentials, as expected. That's the next step, and it costs roughly 15 cents an hour while the cluster exists, so it gets destroyed right after.</a:t>
+              <a:t>init, fmt and validate all pass, and the same checks run in the pipeline on every push. To create the infrastructure you run terraform plan, apply and destroy against an AWS account. It takes about 15 minutes, and costs roughly 15 cents an hour while the cluster exists, so it gets destroyed right after use.</a:t>
             </a:r>
           </a:p>
         </p:txBody>
@@ -2688,7 +2688,7 @@
           <a:p>
             <a:pPr/>
             <a:r>
-              <a:t>The screenshot is the real Argo CD application tree. For the live sync demo I pointed it at a Helm chart that was already on GitHub; once this repo is pushed, the real StockSense Application syncs the same way. Promoting a new build is just changing the image tag in Git: pull request, merge, and Argo CD syncs.</a:t>
+              <a:t>The screenshot is the real Argo CD application tree. For the live sync demo I pointed it at a Helm chart on GitHub, and the real StockSense Application in the gitops folder points at this repo's chart and syncs the same way. Promoting a new build is just changing the image tag in Git: pull request, merge, and Argo CD syncs.</a:t>
             </a:r>
           </a:p>
         </p:txBody>

</xml_diff>